<commit_message>
docs/final deck rebuilt: 30 e2e checks, local-only limitation, corrected closing line
</commit_message>
<xml_diff>
--- a/docs/final/SafeTrail_final_presentation.pptx
+++ b/docs/final/SafeTrail_final_presentation.pptx
@@ -120,21 +120,21 @@
   <p:extLst>
     <p:ext uri="{521415D9-36F7-43E2-AB2F-B90AF26B5E84}">
       <p14:sectionLst xmlns:p14="http://schemas.microsoft.com/office/powerpoint/2010/main">
-        <p14:section name="Introduction" id="{260b93c5-ef5c-93b0-6deb-8d34738db58c}">
+        <p14:section name="Introduction" id="{3db29913-95df-c100-7323-0cdd5e4aa62a}">
           <p14:sldIdLst>
             <p14:sldId id="256"/>
             <p14:sldId id="257"/>
             <p14:sldId id="258"/>
           </p14:sldIdLst>
         </p14:section>
-        <p14:section name="Design" id="{1de9effa-66ec-9ae6-bd85-3cacb9ed9912}">
+        <p14:section name="Design" id="{4112209b-5189-b2c3-3a2f-87b2dd7225a0}">
           <p14:sldIdLst>
             <p14:sldId id="259"/>
             <p14:sldId id="260"/>
             <p14:sldId id="261"/>
           </p14:sldIdLst>
         </p14:section>
-        <p14:section name="Evidence" id="{6f23959e-5896-a242-ece0-aa8cd334a540}">
+        <p14:section name="Evidence" id="{a2ce3c28-07f5-f18a-6b6b-d0bb92bc684b}">
           <p14:sldIdLst>
             <p14:sldId id="262"/>
             <p14:sldId id="263"/>
@@ -142,12 +142,12 @@
             <p14:sldId id="265"/>
           </p14:sldIdLst>
         </p14:section>
-        <p14:section name="Demo" id="{65139468-8e11-8dba-1c29-3d77693c6f7a}">
+        <p14:section name="Demo" id="{29ff625f-f759-ea31-90e3-d9f8285cd109}">
           <p14:sldIdLst>
             <p14:sldId id="266"/>
           </p14:sldIdLst>
         </p14:section>
-        <p14:section name="Close" id="{aa019227-f0c3-5dfd-a020-c95583f6c75d}">
+        <p14:section name="Close" id="{a9514404-ad92-9535-30d1-2cd081940a50}">
           <p14:sldIdLst>
             <p14:sldId id="267"/>
             <p14:sldId id="268"/>
@@ -910,7 +910,7 @@
           <a:p>
             <a:r>
               <a:rPr lang="en-US" dirty="0"/>
-              <a:t>Simulated people; an in-memory server; the OSM hazard polygons are thin, so 'uncertain' is often the honest answer; benchmarks from one laptop. Next: persistence, real GPS traces, a phone app running the same offline evaluator, TLS and Argon2.</a:t>
+              <a:t>Simulated people; an in-memory server that runs on this laptop — the public link is only a static replay; the OSM hazard polygons are thin, so 'uncertain' is often the honest answer; benchmarks from one laptop. Next: persistence, real GPS traces, a phone app running the same offline evaluator, public hosting behind TLS, and Argon2.</a:t>
             </a:r>
             <a:endParaRPr lang="en-US" dirty="0"/>
           </a:p>
@@ -998,7 +998,7 @@
           <a:p>
             <a:r>
               <a:rPr lang="en-US" dirty="0"/>
-              <a:t>Thank you — the code, tests, benchmarks and this deck are in the repository, and every number on these slides is regenerated by make bench.</a:t>
+              <a:t>Thank you — the code, tests, benchmarks and this deck are in the repository, and every benchmark figure on these slides is regenerated by make bench.</a:t>
             </a:r>
             <a:endParaRPr lang="en-US" dirty="0"/>
           </a:p>
@@ -1702,7 +1702,7 @@
           <a:p>
             <a:r>
               <a:rPr lang="en-US" dirty="0"/>
-              <a:t>Every fast structure has an oracle; invariants are checked after every operation; 51 test files, 12,066 checks; 28 injected bugs, all caught; byte-identical output on macOS and Linux.</a:t>
+              <a:t>Every fast structure has an oracle; invariants are checked after every operation; 51 test files, 12,137 checks; 28 injected bugs, all caught; byte-identical output on macOS and Linux.</a:t>
             </a:r>
             <a:endParaRPr lang="en-US" dirty="0"/>
           </a:p>
@@ -5212,6 +5212,24 @@
                   <a:schemeClr val="bg1"/>
                 </a:solidFill>
               </a:rPr>
+              <a:t>Runs locally; the public link is a static replay</a:t>
+            </a:r>
+            <a:endParaRPr lang="en-US" sz="1500" dirty="0"/>
+          </a:p>
+          <a:p>
+            <a:pPr marL="342900" indent="-342900">
+              <a:spcAft>
+                <a:spcPts val="800"/>
+              </a:spcAft>
+              <a:buSzPct val="100000"/>
+              <a:buChar char="•"/>
+            </a:pPr>
+            <a:r>
+              <a:rPr lang="en-US" sz="1500" dirty="0">
+                <a:solidFill>
+                  <a:schemeClr val="bg1"/>
+                </a:solidFill>
+              </a:rPr>
               <a:t>OSM hazard polygons are thin: 'uncertain' is often the honest answer</a:t>
             </a:r>
             <a:endParaRPr lang="en-US" sz="1500" dirty="0"/>
@@ -5423,7 +5441,25 @@
                   <a:schemeClr val="bg1"/>
                 </a:solidFill>
               </a:rPr>
-              <a:t>TLS, Argon2id, external security review</a:t>
+              <a:t>Public hosting behind TLS, with persistence</a:t>
+            </a:r>
+            <a:endParaRPr lang="en-US" sz="1500" dirty="0"/>
+          </a:p>
+          <a:p>
+            <a:pPr marL="342900" indent="-342900">
+              <a:spcAft>
+                <a:spcPts val="800"/>
+              </a:spcAft>
+              <a:buSzPct val="100000"/>
+              <a:buChar char="•"/>
+            </a:pPr>
+            <a:r>
+              <a:rPr lang="en-US" sz="1500" dirty="0">
+                <a:solidFill>
+                  <a:schemeClr val="bg1"/>
+                </a:solidFill>
+              </a:rPr>
+              <a:t>Argon2id, external security review</a:t>
             </a:r>
             <a:endParaRPr lang="en-US" sz="1500" dirty="0"/>
           </a:p>
@@ -5569,7 +5605,7 @@
                   <a:schemeClr val="bg2"/>
                 </a:solidFill>
               </a:rPr>
-              <a:t>Code, tests, benchmarks, report and this deck: github.com/adivishall/safetrail. Every number here is regenerated by make bench.</a:t>
+              <a:t>Code, tests, benchmarks, report and this deck: github.com/adivishall/safetrail. Every benchmark figure here is regenerated by make bench.</a:t>
             </a:r>
             <a:endParaRPr lang="en-US" sz="2000" dirty="0"/>
           </a:p>
@@ -11070,7 +11106,7 @@
                   <a:schemeClr val="accent1"/>
                 </a:solidFill>
               </a:rPr>
-              <a:t>12,066</a:t>
+              <a:t>12,137</a:t>
             </a:r>
             <a:endParaRPr lang="en-US" sz="4000" dirty="0"/>
           </a:p>
@@ -11214,7 +11250,7 @@
                   <a:schemeClr val="accent5"/>
                 </a:solidFill>
               </a:rPr>
-              <a:t>29</a:t>
+              <a:t>30</a:t>
             </a:r>
             <a:endParaRPr lang="en-US" sz="4000" dirty="0"/>
           </a:p>

</xml_diff>